<commit_message>
Rebuild site: manual and wording updates
</commit_message>
<xml_diff>
--- a/en/files/slides/Session_7_EN.pptx
+++ b/en/files/slides/Session_7_EN.pptx
@@ -3934,7 +3934,7 @@
           <a:p>
             <a:r>
               <a:rPr lang="en-US" sz="1400" b="0" dirty="0"/>
-              <a:t>Deadline for the Methods and Results draft: before Session 8 (course folder or email). Next Saturday's workshop adds the Introduction, Discussion, Abstract and Title.</a:t>
+              <a:t>Deadline for the Methods and Results draft: before Session 8 (by email). Next Saturday's workshop adds the Introduction, Discussion, Abstract and Title.</a:t>
             </a:r>
           </a:p>
         </p:txBody>
@@ -26295,7 +26295,7 @@
                 <a:latin typeface="Arial"/>
                 <a:cs typeface="Arial"/>
               </a:rPr>
-              <a:t>Your own Methods and Results (about 600 words), sent to the course folder before Session 8</a:t>
+              <a:t>Your own Methods and Results (about 600 words), sent by email before Session 8</a:t>
             </a:r>
           </a:p>
         </p:txBody>
@@ -26904,7 +26904,7 @@
                 <a:latin typeface="Arial"/>
                 <a:cs typeface="Arial"/>
               </a:rPr>
-              <a:t>Full glossary (English-Vietnamese): Course/References/glossary_EN_VN (PDF in the course folder)</a:t>
+              <a:t>Full glossary (English-Vietnamese): the PDF sent by email</a:t>
             </a:r>
           </a:p>
         </p:txBody>

</xml_diff>

<commit_message>
Rebuild: instructor wording in English, rubric and proposal brief follow-up
</commit_message>
<xml_diff>
--- a/en/files/slides/Session_7_EN.pptx
+++ b/en/files/slides/Session_7_EN.pptx
@@ -2153,7 +2153,7 @@
           <a:p>
             <a:r>
               <a:rPr lang="en-US" sz="1400" b="0" dirty="0"/>
-              <a:t>Homework: Part 4 of their own proposal. Volunteers who want to present email the course lead by Wednesday 16 December.</a:t>
+              <a:t>Homework: Part 4 of their own proposal. Volunteers who want to present email the instructor by Wednesday 16 December.</a:t>
             </a:r>
           </a:p>
         </p:txBody>
@@ -27474,7 +27474,7 @@
                           <a:latin typeface="Arial"/>
                           <a:cs typeface="Arial"/>
                         </a:rPr>
-                        <a:t>Email your Results section to your reviewer and the course lead</a:t>
+                        <a:t>Email your Results section to your reviewer and the instructor</a:t>
                       </a:r>
                     </a:p>
                   </a:txBody>
@@ -27524,7 +27524,7 @@
                           <a:latin typeface="Arial"/>
                           <a:cs typeface="Arial"/>
                         </a:rPr>
-                        <a:t>Reviewers email their review to the author and the course lead</a:t>
+                        <a:t>Reviewers email their review to the author and the instructor</a:t>
                       </a:r>
                     </a:p>
                   </a:txBody>
@@ -27574,7 +27574,7 @@
                           <a:latin typeface="Arial"/>
                           <a:cs typeface="Arial"/>
                         </a:rPr>
-                        <a:t>Email your revised Results section and response letter to the course lead</a:t>
+                        <a:t>Email your revised Results section and response letter to the instructor</a:t>
                       </a:r>
                     </a:p>
                   </a:txBody>
@@ -27623,7 +27623,7 @@
                 <a:latin typeface="Arial"/>
                 <a:cs typeface="Arial"/>
               </a:rPr>
-              <a:t>Reviewers were assigned at random: see the list on screen and in your email. Course lead: myluong1710@gmail.com</a:t>
+              <a:t>Reviewers were assigned at random: see the list on screen and in your email. Instructor: myluong1710@gmail.com</a:t>
             </a:r>
           </a:p>
         </p:txBody>

</xml_diff>